<commit_message>
Use official WCK logo in header and restore verbatim deck copy
Header now uses the official World Central Kitchen logo (transparent
background) on the left with the subtitle beside it, and moves the
WIN STORY pill above the Align HCM + Dayforce logos on the right.

Card copy is transcribed verbatim from the original WCK_Win_Story deck,
including the "--" dashes, the inline "-- Adam Reusing, WCK" attribution,
and the source's exact wording.

Co-Authored-By: Claude Opus 4.8 <noreply@anthropic.com>
Claude-Session: https://claude.ai/code/session_01VnUaj1D5WX83CgY5qm9dDf
</commit_message>
<xml_diff>
--- a/02_FullTimeJob/AlignHCM/win-stories/world-central-kitchen/WCK_Win_Story.pptx
+++ b/02_FullTimeJob/AlignHCM/win-stories/world-central-kitchen/WCK_Win_Story.pptx
@@ -946,148 +946,9 @@
           <a:ln/>
         </p:spPr>
       </p:sp>
-      <p:sp>
-        <p:nvSpPr>
-          <p:cNvPr id="5" name="Shape 3"/>
-          <p:cNvSpPr/>
-          <p:nvPr/>
-        </p:nvSpPr>
-        <p:spPr>
-          <a:xfrm>
-            <a:off x="566928" y="402336"/>
-            <a:ext cx="932688" cy="219456"/>
-          </a:xfrm>
-          <a:prstGeom prst="roundRect">
-            <a:avLst>
-              <a:gd name="adj" fmla="val 20833"/>
-            </a:avLst>
-          </a:prstGeom>
-          <a:solidFill>
-            <a:srgbClr val="E0652F"/>
-          </a:solidFill>
-          <a:ln/>
-        </p:spPr>
-      </p:sp>
-      <p:sp>
-        <p:nvSpPr>
-          <p:cNvPr id="6" name="Text 4"/>
-          <p:cNvSpPr/>
-          <p:nvPr/>
-        </p:nvSpPr>
-        <p:spPr>
-          <a:xfrm>
-            <a:off x="566928" y="402336"/>
-            <a:ext cx="932688" cy="219456"/>
-          </a:xfrm>
-          <a:prstGeom prst="rect">
-            <a:avLst/>
-          </a:prstGeom>
-          <a:noFill/>
-          <a:ln/>
-        </p:spPr>
-        <p:txBody>
-          <a:bodyPr wrap="square" lIns="0" tIns="0" rIns="0" bIns="0" rtlCol="0" anchor="ctr"/>
-          <a:lstStyle/>
-          <a:p>
-            <a:pPr algn="ctr" indent="0" marL="0">
-              <a:buNone/>
-            </a:pPr>
-            <a:r>
-              <a:rPr lang="en-US" sz="850" b="1" spc="100" kern="0" dirty="0">
-                <a:solidFill>
-                  <a:srgbClr val="FFFFFF"/>
-                </a:solidFill>
-                <a:latin typeface="Calibri" pitchFamily="34" charset="0"/>
-                <a:ea typeface="Calibri" pitchFamily="34" charset="-122"/>
-                <a:cs typeface="Calibri" pitchFamily="34" charset="-120"/>
-              </a:rPr>
-              <a:t>WIN STORY</a:t>
-            </a:r>
-            <a:endParaRPr lang="en-US" sz="850" dirty="0"/>
-          </a:p>
-        </p:txBody>
-      </p:sp>
-      <p:sp>
-        <p:nvSpPr>
-          <p:cNvPr id="7" name="Text 5"/>
-          <p:cNvSpPr/>
-          <p:nvPr/>
-        </p:nvSpPr>
-        <p:spPr>
-          <a:xfrm>
-            <a:off x="566928" y="640080"/>
-            <a:ext cx="7863840" cy="420624"/>
-          </a:xfrm>
-          <a:prstGeom prst="rect">
-            <a:avLst/>
-          </a:prstGeom>
-          <a:noFill/>
-          <a:ln/>
-        </p:spPr>
-        <p:txBody>
-          <a:bodyPr wrap="square" lIns="0" tIns="0" rIns="0" bIns="0" rtlCol="0" anchor="ctr"/>
-          <a:lstStyle/>
-          <a:p>
-            <a:pPr algn="l" indent="0" marL="0">
-              <a:buNone/>
-            </a:pPr>
-            <a:r>
-              <a:rPr lang="en-US" sz="2400" b="1" spc="50" kern="0" dirty="0">
-                <a:solidFill>
-                  <a:srgbClr val="FFFFFF"/>
-                </a:solidFill>
-                <a:latin typeface="Calibri" pitchFamily="34" charset="0"/>
-                <a:ea typeface="Calibri" pitchFamily="34" charset="-122"/>
-                <a:cs typeface="Calibri" pitchFamily="34" charset="-120"/>
-              </a:rPr>
-              <a:t>WORLD CENTRAL KITCHEN</a:t>
-            </a:r>
-            <a:endParaRPr lang="en-US" sz="2400" dirty="0"/>
-          </a:p>
-        </p:txBody>
-      </p:sp>
-      <p:sp>
-        <p:nvSpPr>
-          <p:cNvPr id="8" name="Text 6"/>
-          <p:cNvSpPr/>
-          <p:nvPr/>
-        </p:nvSpPr>
-        <p:spPr>
-          <a:xfrm>
-            <a:off x="566928" y="1051560"/>
-            <a:ext cx="7863840" cy="219456"/>
-          </a:xfrm>
-          <a:prstGeom prst="rect">
-            <a:avLst/>
-          </a:prstGeom>
-          <a:noFill/>
-          <a:ln/>
-        </p:spPr>
-        <p:txBody>
-          <a:bodyPr wrap="square" lIns="0" tIns="0" rIns="0" bIns="0" rtlCol="0" anchor="ctr"/>
-          <a:lstStyle/>
-          <a:p>
-            <a:pPr algn="l" indent="0" marL="0">
-              <a:buNone/>
-            </a:pPr>
-            <a:r>
-              <a:rPr lang="en-US" sz="1050" i="1" dirty="0">
-                <a:solidFill>
-                  <a:srgbClr val="C7D2E0"/>
-                </a:solidFill>
-                <a:latin typeface="Calibri" pitchFamily="34" charset="0"/>
-                <a:ea typeface="Calibri" pitchFamily="34" charset="-122"/>
-                <a:cs typeface="Calibri" pitchFamily="34" charset="-120"/>
-              </a:rPr>
-              <a:t>Dayforce Full-Suite Implementation   |   Nonprofit   |   Global Humanitarian</a:t>
-            </a:r>
-            <a:endParaRPr lang="en-US" sz="1050" dirty="0"/>
-          </a:p>
-        </p:txBody>
-      </p:sp>
       <p:pic>
         <p:nvPicPr>
-          <p:cNvPr id="9" name="Image 0" descr="/home/user/dillon-os/02_FullTimeJob/AlignHCM/win-stories/world-central-kitchen/assets/dayforce_logo.png">    </p:cNvPr>
+          <p:cNvPr id="5" name="Image 0" descr="/home/user/dillon-os/02_FullTimeJob/AlignHCM/win-stories/world-central-kitchen/assets/wck_logo.png">    </p:cNvPr>
           <p:cNvPicPr>
             <a:picLocks noChangeAspect="1"/>
           </p:cNvPicPr>
@@ -1101,17 +962,117 @@
         </p:blipFill>
         <p:spPr>
           <a:xfrm>
-            <a:off x="10692079" y="581101"/>
-            <a:ext cx="932688" cy="392278"/>
+            <a:off x="566928" y="448056"/>
+            <a:ext cx="1158728" cy="658368"/>
           </a:xfrm>
           <a:prstGeom prst="rect">
             <a:avLst/>
           </a:prstGeom>
         </p:spPr>
       </p:pic>
+      <p:sp>
+        <p:nvSpPr>
+          <p:cNvPr id="6" name="Text 3"/>
+          <p:cNvSpPr/>
+          <p:nvPr/>
+        </p:nvSpPr>
+        <p:spPr>
+          <a:xfrm>
+            <a:off x="1999976" y="274320"/>
+            <a:ext cx="5486400" cy="1005840"/>
+          </a:xfrm>
+          <a:prstGeom prst="rect">
+            <a:avLst/>
+          </a:prstGeom>
+          <a:noFill/>
+          <a:ln/>
+        </p:spPr>
+        <p:txBody>
+          <a:bodyPr wrap="square" lIns="0" tIns="0" rIns="0" bIns="0" rtlCol="0" anchor="ctr"/>
+          <a:lstStyle/>
+          <a:p>
+            <a:pPr algn="l" indent="0" marL="0">
+              <a:buNone/>
+            </a:pPr>
+            <a:r>
+              <a:rPr lang="en-US" sz="1050" i="1" dirty="0">
+                <a:solidFill>
+                  <a:srgbClr val="C7D2E0"/>
+                </a:solidFill>
+                <a:latin typeface="Calibri" pitchFamily="34" charset="0"/>
+                <a:ea typeface="Calibri" pitchFamily="34" charset="-122"/>
+                <a:cs typeface="Calibri" pitchFamily="34" charset="-120"/>
+              </a:rPr>
+              <a:t>Dayforce Full-Suite Implementation   |   Nonprofit   |   Global Humanitarian</a:t>
+            </a:r>
+            <a:endParaRPr lang="en-US" sz="1050" dirty="0"/>
+          </a:p>
+        </p:txBody>
+      </p:sp>
+      <p:sp>
+        <p:nvSpPr>
+          <p:cNvPr id="7" name="Shape 4"/>
+          <p:cNvSpPr/>
+          <p:nvPr/>
+        </p:nvSpPr>
+        <p:spPr>
+          <a:xfrm>
+            <a:off x="10692079" y="365760"/>
+            <a:ext cx="932688" cy="219456"/>
+          </a:xfrm>
+          <a:prstGeom prst="roundRect">
+            <a:avLst>
+              <a:gd name="adj" fmla="val 20833"/>
+            </a:avLst>
+          </a:prstGeom>
+          <a:solidFill>
+            <a:srgbClr val="E0652F"/>
+          </a:solidFill>
+          <a:ln/>
+        </p:spPr>
+      </p:sp>
+      <p:sp>
+        <p:nvSpPr>
+          <p:cNvPr id="8" name="Text 5"/>
+          <p:cNvSpPr/>
+          <p:nvPr/>
+        </p:nvSpPr>
+        <p:spPr>
+          <a:xfrm>
+            <a:off x="10692079" y="365760"/>
+            <a:ext cx="932688" cy="219456"/>
+          </a:xfrm>
+          <a:prstGeom prst="rect">
+            <a:avLst/>
+          </a:prstGeom>
+          <a:noFill/>
+          <a:ln/>
+        </p:spPr>
+        <p:txBody>
+          <a:bodyPr wrap="square" lIns="0" tIns="0" rIns="0" bIns="0" rtlCol="0" anchor="ctr"/>
+          <a:lstStyle/>
+          <a:p>
+            <a:pPr algn="ctr" indent="0" marL="0">
+              <a:buNone/>
+            </a:pPr>
+            <a:r>
+              <a:rPr lang="en-US" sz="850" b="1" spc="100" kern="0" dirty="0">
+                <a:solidFill>
+                  <a:srgbClr val="FFFFFF"/>
+                </a:solidFill>
+                <a:latin typeface="Calibri" pitchFamily="34" charset="0"/>
+                <a:ea typeface="Calibri" pitchFamily="34" charset="-122"/>
+                <a:cs typeface="Calibri" pitchFamily="34" charset="-120"/>
+              </a:rPr>
+              <a:t>WIN STORY</a:t>
+            </a:r>
+            <a:endParaRPr lang="en-US" sz="850" dirty="0"/>
+          </a:p>
+        </p:txBody>
+      </p:sp>
       <p:pic>
         <p:nvPicPr>
-          <p:cNvPr id="10" name="Image 1" descr="/home/user/dillon-os/02_FullTimeJob/AlignHCM/win-stories/world-central-kitchen/assets/align_logo.png">    </p:cNvPr>
+          <p:cNvPr id="9" name="Image 1" descr="/home/user/dillon-os/02_FullTimeJob/AlignHCM/win-stories/world-central-kitchen/assets/dayforce_logo.png">    </p:cNvPr>
           <p:cNvPicPr>
             <a:picLocks noChangeAspect="1"/>
           </p:cNvPicPr>
@@ -1125,7 +1086,31 @@
         </p:blipFill>
         <p:spPr>
           <a:xfrm>
-            <a:off x="9594799" y="548640"/>
+            <a:off x="10692079" y="690829"/>
+            <a:ext cx="932688" cy="392278"/>
+          </a:xfrm>
+          <a:prstGeom prst="rect">
+            <a:avLst/>
+          </a:prstGeom>
+        </p:spPr>
+      </p:pic>
+      <p:pic>
+        <p:nvPicPr>
+          <p:cNvPr id="10" name="Image 2" descr="/home/user/dillon-os/02_FullTimeJob/AlignHCM/win-stories/world-central-kitchen/assets/align_logo.png">    </p:cNvPr>
+          <p:cNvPicPr>
+            <a:picLocks noChangeAspect="1"/>
+          </p:cNvPicPr>
+          <p:nvPr/>
+        </p:nvPicPr>
+        <p:blipFill>
+          <a:blip r:embed="rId3"/>
+          <a:stretch>
+            <a:fillRect/>
+          </a:stretch>
+        </p:blipFill>
+        <p:spPr>
+          <a:xfrm>
+            <a:off x="9594799" y="658368"/>
             <a:ext cx="914400" cy="457200"/>
           </a:xfrm>
           <a:prstGeom prst="rect">
@@ -1135,7 +1120,7 @@
       </p:pic>
       <p:sp>
         <p:nvSpPr>
-          <p:cNvPr id="11" name="Shape 7"/>
+          <p:cNvPr id="11" name="Shape 6"/>
           <p:cNvSpPr/>
           <p:nvPr/>
         </p:nvSpPr>
@@ -1155,7 +1140,7 @@
       </p:sp>
       <p:sp>
         <p:nvSpPr>
-          <p:cNvPr id="12" name="Text 8"/>
+          <p:cNvPr id="12" name="Text 7"/>
           <p:cNvSpPr/>
           <p:nvPr/>
         </p:nvSpPr>
@@ -1194,7 +1179,7 @@
       </p:sp>
       <p:sp>
         <p:nvSpPr>
-          <p:cNvPr id="13" name="Text 9"/>
+          <p:cNvPr id="13" name="Text 8"/>
           <p:cNvSpPr/>
           <p:nvPr/>
         </p:nvSpPr>
@@ -1233,7 +1218,7 @@
       </p:sp>
       <p:sp>
         <p:nvSpPr>
-          <p:cNvPr id="14" name="Shape 10"/>
+          <p:cNvPr id="14" name="Shape 9"/>
           <p:cNvSpPr/>
           <p:nvPr/>
         </p:nvSpPr>
@@ -1256,7 +1241,7 @@
       </p:sp>
       <p:sp>
         <p:nvSpPr>
-          <p:cNvPr id="15" name="Text 11"/>
+          <p:cNvPr id="15" name="Text 10"/>
           <p:cNvSpPr/>
           <p:nvPr/>
         </p:nvSpPr>
@@ -1295,7 +1280,7 @@
       </p:sp>
       <p:sp>
         <p:nvSpPr>
-          <p:cNvPr id="16" name="Text 12"/>
+          <p:cNvPr id="16" name="Text 11"/>
           <p:cNvSpPr/>
           <p:nvPr/>
         </p:nvSpPr>
@@ -1334,7 +1319,7 @@
       </p:sp>
       <p:sp>
         <p:nvSpPr>
-          <p:cNvPr id="17" name="Shape 13"/>
+          <p:cNvPr id="17" name="Shape 12"/>
           <p:cNvSpPr/>
           <p:nvPr/>
         </p:nvSpPr>
@@ -1357,7 +1342,7 @@
       </p:sp>
       <p:sp>
         <p:nvSpPr>
-          <p:cNvPr id="18" name="Text 14"/>
+          <p:cNvPr id="18" name="Text 13"/>
           <p:cNvSpPr/>
           <p:nvPr/>
         </p:nvSpPr>
@@ -1396,7 +1381,7 @@
       </p:sp>
       <p:sp>
         <p:nvSpPr>
-          <p:cNvPr id="19" name="Text 15"/>
+          <p:cNvPr id="19" name="Text 14"/>
           <p:cNvSpPr/>
           <p:nvPr/>
         </p:nvSpPr>
@@ -1435,7 +1420,7 @@
       </p:sp>
       <p:sp>
         <p:nvSpPr>
-          <p:cNvPr id="20" name="Shape 16"/>
+          <p:cNvPr id="20" name="Shape 15"/>
           <p:cNvSpPr/>
           <p:nvPr/>
         </p:nvSpPr>
@@ -1458,7 +1443,7 @@
       </p:sp>
       <p:sp>
         <p:nvSpPr>
-          <p:cNvPr id="21" name="Text 17"/>
+          <p:cNvPr id="21" name="Text 16"/>
           <p:cNvSpPr/>
           <p:nvPr/>
         </p:nvSpPr>
@@ -1497,7 +1482,7 @@
       </p:sp>
       <p:sp>
         <p:nvSpPr>
-          <p:cNvPr id="22" name="Text 18"/>
+          <p:cNvPr id="22" name="Text 17"/>
           <p:cNvSpPr/>
           <p:nvPr/>
         </p:nvSpPr>
@@ -1536,7 +1521,7 @@
       </p:sp>
       <p:sp>
         <p:nvSpPr>
-          <p:cNvPr id="23" name="Shape 19"/>
+          <p:cNvPr id="23" name="Shape 18"/>
           <p:cNvSpPr/>
           <p:nvPr/>
         </p:nvSpPr>
@@ -1559,7 +1544,7 @@
       </p:sp>
       <p:sp>
         <p:nvSpPr>
-          <p:cNvPr id="24" name="Text 20"/>
+          <p:cNvPr id="24" name="Text 19"/>
           <p:cNvSpPr/>
           <p:nvPr/>
         </p:nvSpPr>
@@ -1598,7 +1583,7 @@
       </p:sp>
       <p:sp>
         <p:nvSpPr>
-          <p:cNvPr id="25" name="Text 21"/>
+          <p:cNvPr id="25" name="Text 20"/>
           <p:cNvSpPr/>
           <p:nvPr/>
         </p:nvSpPr>
@@ -1637,7 +1622,7 @@
       </p:sp>
       <p:sp>
         <p:nvSpPr>
-          <p:cNvPr id="26" name="Shape 22"/>
+          <p:cNvPr id="26" name="Shape 21"/>
           <p:cNvSpPr/>
           <p:nvPr/>
         </p:nvSpPr>
@@ -1660,7 +1645,7 @@
       </p:sp>
       <p:sp>
         <p:nvSpPr>
-          <p:cNvPr id="27" name="Text 23"/>
+          <p:cNvPr id="27" name="Text 22"/>
           <p:cNvSpPr/>
           <p:nvPr/>
         </p:nvSpPr>
@@ -1699,7 +1684,7 @@
       </p:sp>
       <p:sp>
         <p:nvSpPr>
-          <p:cNvPr id="28" name="Text 24"/>
+          <p:cNvPr id="28" name="Text 23"/>
           <p:cNvSpPr/>
           <p:nvPr/>
         </p:nvSpPr>
@@ -1738,7 +1723,7 @@
       </p:sp>
       <p:sp>
         <p:nvSpPr>
-          <p:cNvPr id="29" name="Shape 25"/>
+          <p:cNvPr id="29" name="Shape 24"/>
           <p:cNvSpPr/>
           <p:nvPr/>
         </p:nvSpPr>
@@ -1760,7 +1745,7 @@
       </p:sp>
       <p:sp>
         <p:nvSpPr>
-          <p:cNvPr id="30" name="Text 26"/>
+          <p:cNvPr id="30" name="Text 25"/>
           <p:cNvSpPr/>
           <p:nvPr/>
         </p:nvSpPr>
@@ -1799,7 +1784,7 @@
       </p:sp>
       <p:sp>
         <p:nvSpPr>
-          <p:cNvPr id="31" name="Text 27"/>
+          <p:cNvPr id="31" name="Text 26"/>
           <p:cNvSpPr/>
           <p:nvPr/>
         </p:nvSpPr>
@@ -1838,7 +1823,7 @@
       </p:sp>
       <p:sp>
         <p:nvSpPr>
-          <p:cNvPr id="32" name="Shape 28"/>
+          <p:cNvPr id="32" name="Shape 27"/>
           <p:cNvSpPr/>
           <p:nvPr/>
         </p:nvSpPr>
@@ -1865,7 +1850,7 @@
       </p:sp>
       <p:sp>
         <p:nvSpPr>
-          <p:cNvPr id="33" name="Text 29"/>
+          <p:cNvPr id="33" name="Text 28"/>
           <p:cNvSpPr/>
           <p:nvPr/>
         </p:nvSpPr>
@@ -1922,7 +1907,7 @@
                 <a:ea typeface="Calibri" pitchFamily="34" charset="-122"/>
                 <a:cs typeface="Calibri" pitchFamily="34" charset="-120"/>
               </a:rPr>
-              <a:t>WCK operated across BambooHR, Airtable, Gmail-based approvals, and A3innuva with no unified HR platform, creating data gaps, manual errors, and compliance exposure across 24 countries and multiple entity structures.</a:t>
+              <a:t>WCK operated across BambooHR, Airtable, Gmail-based approvals, and A3innuva with no unified HR platform -- creating data gaps, manual errors, and compliance exposure across 24 countries and multiple entity structures.</a:t>
             </a:r>
             <a:endParaRPr lang="en-US" sz="1050" dirty="0"/>
           </a:p>
@@ -1930,7 +1915,7 @@
       </p:sp>
       <p:sp>
         <p:nvSpPr>
-          <p:cNvPr id="34" name="Shape 30"/>
+          <p:cNvPr id="34" name="Shape 29"/>
           <p:cNvSpPr/>
           <p:nvPr/>
         </p:nvSpPr>
@@ -1957,7 +1942,7 @@
       </p:sp>
       <p:sp>
         <p:nvSpPr>
-          <p:cNvPr id="35" name="Text 31"/>
+          <p:cNvPr id="35" name="Text 30"/>
           <p:cNvSpPr/>
           <p:nvPr/>
         </p:nvSpPr>
@@ -2022,7 +2007,7 @@
       </p:sp>
       <p:sp>
         <p:nvSpPr>
-          <p:cNvPr id="36" name="Shape 32"/>
+          <p:cNvPr id="36" name="Shape 31"/>
           <p:cNvSpPr/>
           <p:nvPr/>
         </p:nvSpPr>
@@ -2049,7 +2034,7 @@
       </p:sp>
       <p:sp>
         <p:nvSpPr>
-          <p:cNvPr id="37" name="Text 33"/>
+          <p:cNvPr id="37" name="Text 32"/>
           <p:cNvSpPr/>
           <p:nvPr/>
         </p:nvSpPr>
@@ -2106,7 +2091,7 @@
                 <a:ea typeface="Calibri" pitchFamily="34" charset="-122"/>
                 <a:cs typeface="Calibri" pitchFamily="34" charset="-120"/>
               </a:rPr>
-              <a:t>A hard January 1 go-live date required simultaneous Sage Intacct integration from day one, leaving zero runway for a phased finance cutover. Bilingual (EN/ES) delivery was also required from the start.</a:t>
+              <a:t>A hard January 1 go-live date required simultaneous Sage Intacct integration from day one -- leaving zero runway for a phased finance cutover. Bilingual (EN/ES) delivery was also required from the start.</a:t>
             </a:r>
             <a:endParaRPr lang="en-US" sz="1050" dirty="0"/>
           </a:p>
@@ -2114,7 +2099,7 @@
       </p:sp>
       <p:sp>
         <p:nvSpPr>
-          <p:cNvPr id="38" name="Shape 34"/>
+          <p:cNvPr id="38" name="Shape 33"/>
           <p:cNvSpPr/>
           <p:nvPr/>
         </p:nvSpPr>
@@ -2136,7 +2121,7 @@
       </p:sp>
       <p:sp>
         <p:nvSpPr>
-          <p:cNvPr id="39" name="Text 35"/>
+          <p:cNvPr id="39" name="Text 34"/>
           <p:cNvSpPr/>
           <p:nvPr/>
         </p:nvSpPr>
@@ -2175,7 +2160,7 @@
       </p:sp>
       <p:sp>
         <p:nvSpPr>
-          <p:cNvPr id="40" name="Text 36"/>
+          <p:cNvPr id="40" name="Text 35"/>
           <p:cNvSpPr/>
           <p:nvPr/>
         </p:nvSpPr>
@@ -2214,7 +2199,7 @@
       </p:sp>
       <p:sp>
         <p:nvSpPr>
-          <p:cNvPr id="41" name="Shape 37"/>
+          <p:cNvPr id="41" name="Shape 36"/>
           <p:cNvSpPr/>
           <p:nvPr/>
         </p:nvSpPr>
@@ -2241,7 +2226,7 @@
       </p:sp>
       <p:sp>
         <p:nvSpPr>
-          <p:cNvPr id="42" name="Text 38"/>
+          <p:cNvPr id="42" name="Text 37"/>
           <p:cNvSpPr/>
           <p:nvPr/>
         </p:nvSpPr>
@@ -2298,7 +2283,7 @@
                 <a:ea typeface="Calibri" pitchFamily="34" charset="-122"/>
                 <a:cs typeface="Calibri" pitchFamily="34" charset="-120"/>
               </a:rPr>
-              <a:t>Align designed a scalable Relief Contractor onboarding workflow built for humanitarian surge operations: bilingual, field-deployable, and configured for multi-country compliance from day one. No other bidder offered this.</a:t>
+              <a:t>Align designed a scalable Relief Contractor onboarding workflow built for humanitarian surge operations -- bilingual, field-deployable, and configured for multi-country compliance from day one. No other bidder offered this.</a:t>
             </a:r>
             <a:endParaRPr lang="en-US" sz="1050" dirty="0"/>
           </a:p>
@@ -2306,7 +2291,7 @@
       </p:sp>
       <p:sp>
         <p:nvSpPr>
-          <p:cNvPr id="43" name="Shape 39"/>
+          <p:cNvPr id="43" name="Shape 38"/>
           <p:cNvSpPr/>
           <p:nvPr/>
         </p:nvSpPr>
@@ -2333,7 +2318,7 @@
       </p:sp>
       <p:sp>
         <p:nvSpPr>
-          <p:cNvPr id="44" name="Text 40"/>
+          <p:cNvPr id="44" name="Text 39"/>
           <p:cNvSpPr/>
           <p:nvPr/>
         </p:nvSpPr>
@@ -2390,35 +2375,15 @@
                 <a:ea typeface="Calibri" pitchFamily="34" charset="-122"/>
                 <a:cs typeface="Calibri" pitchFamily="34" charset="-120"/>
               </a:rPr>
-              <a:t>“Align HCM has clearly done its homework on WCK’s complexity... The RC surge onboarding model, bilingual delivery, Sage Intacct Day 1 integration, and the mission give-back commitment all stood out.”</a:t>
+              <a:t>"Align HCM has clearly done its homework on WCK's complexity... The RC surge onboarding model, bilingual delivery, Sage Intacct Day 1 integration, and the mission give-back commitment all stood out." -- Adam Reusing, WCK</a:t>
             </a:r>
             <a:endParaRPr lang="en-US" sz="1050" dirty="0"/>
           </a:p>
-          <a:p>
-            <a:pPr algn="l" indent="0" marL="0">
-              <a:lnSpc>
-                <a:spcPct val="98000"/>
-              </a:lnSpc>
-              <a:buNone/>
-            </a:pPr>
-            <a:r>
-              <a:rPr lang="en-US" sz="850" b="1" i="1" dirty="0">
-                <a:solidFill>
-                  <a:srgbClr val="C85A28"/>
-                </a:solidFill>
-                <a:latin typeface="Calibri" pitchFamily="34" charset="0"/>
-                <a:ea typeface="Calibri" pitchFamily="34" charset="-122"/>
-                <a:cs typeface="Calibri" pitchFamily="34" charset="-120"/>
-              </a:rPr>
-              <a:t>Adam Reusing, WCK</a:t>
-            </a:r>
-            <a:endParaRPr lang="en-US" sz="1050" dirty="0"/>
-          </a:p>
-        </p:txBody>
-      </p:sp>
-      <p:sp>
-        <p:nvSpPr>
-          <p:cNvPr id="45" name="Shape 41"/>
+        </p:txBody>
+      </p:sp>
+      <p:sp>
+        <p:nvSpPr>
+          <p:cNvPr id="45" name="Shape 40"/>
           <p:cNvSpPr/>
           <p:nvPr/>
         </p:nvSpPr>
@@ -2445,7 +2410,7 @@
       </p:sp>
       <p:sp>
         <p:nvSpPr>
-          <p:cNvPr id="46" name="Text 42"/>
+          <p:cNvPr id="46" name="Text 41"/>
           <p:cNvSpPr/>
           <p:nvPr/>
         </p:nvSpPr>
@@ -2502,7 +2467,7 @@
                 <a:ea typeface="Calibri" pitchFamily="34" charset="-122"/>
                 <a:cs typeface="Calibri" pitchFamily="34" charset="-120"/>
               </a:rPr>
-              <a:t>Align’s proven Sage Intacct integration capability directly resolved WCK’s highest-risk requirement. Paired with bilingual delivery, Align was the only vendor that could credibly commit to the full scope on the Jan 1 timeline.</a:t>
+              <a:t>Align's proven Sage Intacct integration capability directly resolved WCK's highest-risk requirement. Paired with bilingual delivery, Align was the only vendor that could credibly commit to the full scope on the Jan 1 timeline.</a:t>
             </a:r>
             <a:endParaRPr lang="en-US" sz="1050" dirty="0"/>
           </a:p>
@@ -2510,7 +2475,7 @@
       </p:sp>
       <p:sp>
         <p:nvSpPr>
-          <p:cNvPr id="47" name="Shape 43"/>
+          <p:cNvPr id="47" name="Shape 42"/>
           <p:cNvSpPr/>
           <p:nvPr/>
         </p:nvSpPr>
@@ -2532,7 +2497,7 @@
       </p:sp>
       <p:sp>
         <p:nvSpPr>
-          <p:cNvPr id="48" name="Text 44"/>
+          <p:cNvPr id="48" name="Text 43"/>
           <p:cNvSpPr/>
           <p:nvPr/>
         </p:nvSpPr>
@@ -2571,7 +2536,7 @@
       </p:sp>
       <p:sp>
         <p:nvSpPr>
-          <p:cNvPr id="49" name="Text 45"/>
+          <p:cNvPr id="49" name="Text 44"/>
           <p:cNvSpPr/>
           <p:nvPr/>
         </p:nvSpPr>
@@ -2610,7 +2575,7 @@
       </p:sp>
       <p:sp>
         <p:nvSpPr>
-          <p:cNvPr id="50" name="Shape 46"/>
+          <p:cNvPr id="50" name="Shape 45"/>
           <p:cNvSpPr/>
           <p:nvPr/>
         </p:nvSpPr>
@@ -2637,7 +2602,7 @@
       </p:sp>
       <p:sp>
         <p:nvSpPr>
-          <p:cNvPr id="51" name="Text 47"/>
+          <p:cNvPr id="51" name="Text 46"/>
           <p:cNvSpPr/>
           <p:nvPr/>
         </p:nvSpPr>
@@ -2702,7 +2667,7 @@
       </p:sp>
       <p:sp>
         <p:nvSpPr>
-          <p:cNvPr id="52" name="Shape 48"/>
+          <p:cNvPr id="52" name="Shape 47"/>
           <p:cNvSpPr/>
           <p:nvPr/>
         </p:nvSpPr>
@@ -2729,7 +2694,7 @@
       </p:sp>
       <p:sp>
         <p:nvSpPr>
-          <p:cNvPr id="53" name="Text 49"/>
+          <p:cNvPr id="53" name="Text 48"/>
           <p:cNvSpPr/>
           <p:nvPr/>
         </p:nvSpPr>
@@ -2786,7 +2751,7 @@
                 <a:ea typeface="Calibri" pitchFamily="34" charset="-122"/>
                 <a:cs typeface="Calibri" pitchFamily="34" charset="-120"/>
               </a:rPr>
-              <a:t>Align and WCK co-developed a detailed Implementation Solutions Design and Statement of Work across 8+ working sessions. WCK had line-by-line ownership of scope, timeline, and deliverables. A depth of collaboration no competitor came close to replicating.</a:t>
+              <a:t>Align and WCK co-developed a detailed Implementation Solutions Design and Statement of Work across 8+ working sessions. WCK had line-by-line ownership of scope, timeline, and deliverables -- a depth of collaboration no competitor came close to replicating.</a:t>
             </a:r>
             <a:endParaRPr lang="en-US" sz="1050" dirty="0"/>
           </a:p>
@@ -2794,7 +2759,7 @@
       </p:sp>
       <p:sp>
         <p:nvSpPr>
-          <p:cNvPr id="54" name="Shape 50"/>
+          <p:cNvPr id="54" name="Shape 49"/>
           <p:cNvSpPr/>
           <p:nvPr/>
         </p:nvSpPr>
@@ -2821,7 +2786,7 @@
       </p:sp>
       <p:sp>
         <p:nvSpPr>
-          <p:cNvPr id="55" name="Text 51"/>
+          <p:cNvPr id="55" name="Text 50"/>
           <p:cNvSpPr/>
           <p:nvPr/>
         </p:nvSpPr>
@@ -2878,7 +2843,7 @@
                 <a:ea typeface="Calibri" pitchFamily="34" charset="-122"/>
                 <a:cs typeface="Calibri" pitchFamily="34" charset="-120"/>
               </a:rPr>
-              <a:t>Align demonstrated flexibility on both commercial terms and rate structure. Willingness to adapt without compromising delivery quality sealed the partnership.</a:t>
+              <a:t>Align demonstrated flexibility on both commercial terms and rate structure Willingness to adapt without compromising delivery quality sealed the partnership.</a:t>
             </a:r>
             <a:endParaRPr lang="en-US" sz="1050" dirty="0"/>
           </a:p>

</xml_diff>

<commit_message>
Use clean Dayforce + Align logos in header (backgrounds removed)
Replace the header vendor marks with the real, background-free logos:
Dayforce recolored to solid brand blue via alpha keying, and the Align
logo re-keyed from a clean source with no orange border box (fixes the
prior outline). Both sit directly on the navy header with no boxes, sized
for balanced optical weight, WIN STORY pill centered above them.

Co-Authored-By: Claude Opus 4.8 <noreply@anthropic.com>
Claude-Session: https://claude.ai/code/session_01VnUaj1D5WX83CgY5qm9dDf
</commit_message>
<xml_diff>
--- a/02_FullTimeJob/AlignHCM/win-stories/world-central-kitchen/WCK_Win_Story.pptx
+++ b/02_FullTimeJob/AlignHCM/win-stories/world-central-kitchen/WCK_Win_Story.pptx
@@ -1009,70 +1009,9 @@
           </a:p>
         </p:txBody>
       </p:sp>
-      <p:sp>
-        <p:nvSpPr>
-          <p:cNvPr id="7" name="Shape 4"/>
-          <p:cNvSpPr/>
-          <p:nvPr/>
-        </p:nvSpPr>
-        <p:spPr>
-          <a:xfrm>
-            <a:off x="10692079" y="365760"/>
-            <a:ext cx="932688" cy="219456"/>
-          </a:xfrm>
-          <a:prstGeom prst="roundRect">
-            <a:avLst>
-              <a:gd name="adj" fmla="val 20833"/>
-            </a:avLst>
-          </a:prstGeom>
-          <a:solidFill>
-            <a:srgbClr val="E0652F"/>
-          </a:solidFill>
-          <a:ln/>
-        </p:spPr>
-      </p:sp>
-      <p:sp>
-        <p:nvSpPr>
-          <p:cNvPr id="8" name="Text 5"/>
-          <p:cNvSpPr/>
-          <p:nvPr/>
-        </p:nvSpPr>
-        <p:spPr>
-          <a:xfrm>
-            <a:off x="10692079" y="365760"/>
-            <a:ext cx="932688" cy="219456"/>
-          </a:xfrm>
-          <a:prstGeom prst="rect">
-            <a:avLst/>
-          </a:prstGeom>
-          <a:noFill/>
-          <a:ln/>
-        </p:spPr>
-        <p:txBody>
-          <a:bodyPr wrap="square" lIns="0" tIns="0" rIns="0" bIns="0" rtlCol="0" anchor="ctr"/>
-          <a:lstStyle/>
-          <a:p>
-            <a:pPr algn="ctr" indent="0" marL="0">
-              <a:buNone/>
-            </a:pPr>
-            <a:r>
-              <a:rPr lang="en-US" sz="850" b="1" spc="100" kern="0" dirty="0">
-                <a:solidFill>
-                  <a:srgbClr val="FFFFFF"/>
-                </a:solidFill>
-                <a:latin typeface="Calibri" pitchFamily="34" charset="0"/>
-                <a:ea typeface="Calibri" pitchFamily="34" charset="-122"/>
-                <a:cs typeface="Calibri" pitchFamily="34" charset="-120"/>
-              </a:rPr>
-              <a:t>WIN STORY</a:t>
-            </a:r>
-            <a:endParaRPr lang="en-US" sz="850" dirty="0"/>
-          </a:p>
-        </p:txBody>
-      </p:sp>
       <p:pic>
         <p:nvPicPr>
-          <p:cNvPr id="9" name="Image 1" descr="/home/user/dillon-os/02_FullTimeJob/AlignHCM/win-stories/world-central-kitchen/assets/dayforce_logo.png">    </p:cNvPr>
+          <p:cNvPr id="7" name="Image 1" descr="/home/user/dillon-os/02_FullTimeJob/AlignHCM/win-stories/world-central-kitchen/assets/align_logo.png">    </p:cNvPr>
           <p:cNvPicPr>
             <a:picLocks noChangeAspect="1"/>
           </p:cNvPicPr>
@@ -1086,8 +1025,8 @@
         </p:blipFill>
         <p:spPr>
           <a:xfrm>
-            <a:off x="10692079" y="690829"/>
-            <a:ext cx="932688" cy="392278"/>
+            <a:off x="9223406" y="704088"/>
+            <a:ext cx="986784" cy="420624"/>
           </a:xfrm>
           <a:prstGeom prst="rect">
             <a:avLst/>
@@ -1096,7 +1035,7 @@
       </p:pic>
       <p:pic>
         <p:nvPicPr>
-          <p:cNvPr id="10" name="Image 2" descr="/home/user/dillon-os/02_FullTimeJob/AlignHCM/win-stories/world-central-kitchen/assets/align_logo.png">    </p:cNvPr>
+          <p:cNvPr id="8" name="Image 2" descr="/home/user/dillon-os/02_FullTimeJob/AlignHCM/win-stories/world-central-kitchen/assets/dayforce_logo.png">    </p:cNvPr>
           <p:cNvPicPr>
             <a:picLocks noChangeAspect="1"/>
           </p:cNvPicPr>
@@ -1110,14 +1049,75 @@
         </p:blipFill>
         <p:spPr>
           <a:xfrm>
-            <a:off x="9594799" y="658368"/>
-            <a:ext cx="914400" cy="457200"/>
+            <a:off x="10502798" y="777274"/>
+            <a:ext cx="1121969" cy="274253"/>
           </a:xfrm>
           <a:prstGeom prst="rect">
             <a:avLst/>
           </a:prstGeom>
         </p:spPr>
       </p:pic>
+      <p:sp>
+        <p:nvSpPr>
+          <p:cNvPr id="9" name="Shape 4"/>
+          <p:cNvSpPr/>
+          <p:nvPr/>
+        </p:nvSpPr>
+        <p:spPr>
+          <a:xfrm>
+            <a:off x="9957743" y="384048"/>
+            <a:ext cx="932688" cy="219456"/>
+          </a:xfrm>
+          <a:prstGeom prst="roundRect">
+            <a:avLst>
+              <a:gd name="adj" fmla="val 20833"/>
+            </a:avLst>
+          </a:prstGeom>
+          <a:solidFill>
+            <a:srgbClr val="E0652F"/>
+          </a:solidFill>
+          <a:ln/>
+        </p:spPr>
+      </p:sp>
+      <p:sp>
+        <p:nvSpPr>
+          <p:cNvPr id="10" name="Text 5"/>
+          <p:cNvSpPr/>
+          <p:nvPr/>
+        </p:nvSpPr>
+        <p:spPr>
+          <a:xfrm>
+            <a:off x="9957743" y="384048"/>
+            <a:ext cx="932688" cy="219456"/>
+          </a:xfrm>
+          <a:prstGeom prst="rect">
+            <a:avLst/>
+          </a:prstGeom>
+          <a:noFill/>
+          <a:ln/>
+        </p:spPr>
+        <p:txBody>
+          <a:bodyPr wrap="square" lIns="0" tIns="0" rIns="0" bIns="0" rtlCol="0" anchor="ctr"/>
+          <a:lstStyle/>
+          <a:p>
+            <a:pPr algn="ctr" indent="0" marL="0">
+              <a:buNone/>
+            </a:pPr>
+            <a:r>
+              <a:rPr lang="en-US" sz="850" b="1" spc="100" kern="0" dirty="0">
+                <a:solidFill>
+                  <a:srgbClr val="FFFFFF"/>
+                </a:solidFill>
+                <a:latin typeface="Calibri" pitchFamily="34" charset="0"/>
+                <a:ea typeface="Calibri" pitchFamily="34" charset="-122"/>
+                <a:cs typeface="Calibri" pitchFamily="34" charset="-120"/>
+              </a:rPr>
+              <a:t>WIN STORY</a:t>
+            </a:r>
+            <a:endParaRPr lang="en-US" sz="850" dirty="0"/>
+          </a:p>
+        </p:txBody>
+      </p:sp>
       <p:sp>
         <p:nvSpPr>
           <p:cNvPr id="11" name="Shape 6"/>

</xml_diff>

<commit_message>
Move WIN STORY pill to top-right corner, away from vendor logos
Pin the WIN STORY pill to the top-right corner of the header and drop
the Align + Dayforce logos into the lower band so the two no longer
crowd each other.

Co-Authored-By: Claude Opus 4.8 <noreply@anthropic.com>
Claude-Session: https://claude.ai/code/session_01VnUaj1D5WX83CgY5qm9dDf
</commit_message>
<xml_diff>
--- a/02_FullTimeJob/AlignHCM/win-stories/world-central-kitchen/WCK_Win_Story.pptx
+++ b/02_FullTimeJob/AlignHCM/win-stories/world-central-kitchen/WCK_Win_Story.pptx
@@ -1009,9 +1009,70 @@
           </a:p>
         </p:txBody>
       </p:sp>
+      <p:sp>
+        <p:nvSpPr>
+          <p:cNvPr id="7" name="Shape 4"/>
+          <p:cNvSpPr/>
+          <p:nvPr/>
+        </p:nvSpPr>
+        <p:spPr>
+          <a:xfrm>
+            <a:off x="10692079" y="301752"/>
+            <a:ext cx="932688" cy="219456"/>
+          </a:xfrm>
+          <a:prstGeom prst="roundRect">
+            <a:avLst>
+              <a:gd name="adj" fmla="val 20833"/>
+            </a:avLst>
+          </a:prstGeom>
+          <a:solidFill>
+            <a:srgbClr val="E0652F"/>
+          </a:solidFill>
+          <a:ln/>
+        </p:spPr>
+      </p:sp>
+      <p:sp>
+        <p:nvSpPr>
+          <p:cNvPr id="8" name="Text 5"/>
+          <p:cNvSpPr/>
+          <p:nvPr/>
+        </p:nvSpPr>
+        <p:spPr>
+          <a:xfrm>
+            <a:off x="10692079" y="301752"/>
+            <a:ext cx="932688" cy="219456"/>
+          </a:xfrm>
+          <a:prstGeom prst="rect">
+            <a:avLst/>
+          </a:prstGeom>
+          <a:noFill/>
+          <a:ln/>
+        </p:spPr>
+        <p:txBody>
+          <a:bodyPr wrap="square" lIns="0" tIns="0" rIns="0" bIns="0" rtlCol="0" anchor="ctr"/>
+          <a:lstStyle/>
+          <a:p>
+            <a:pPr algn="ctr" indent="0" marL="0">
+              <a:buNone/>
+            </a:pPr>
+            <a:r>
+              <a:rPr lang="en-US" sz="850" b="1" spc="100" kern="0" dirty="0">
+                <a:solidFill>
+                  <a:srgbClr val="FFFFFF"/>
+                </a:solidFill>
+                <a:latin typeface="Calibri" pitchFamily="34" charset="0"/>
+                <a:ea typeface="Calibri" pitchFamily="34" charset="-122"/>
+                <a:cs typeface="Calibri" pitchFamily="34" charset="-120"/>
+              </a:rPr>
+              <a:t>WIN STORY</a:t>
+            </a:r>
+            <a:endParaRPr lang="en-US" sz="850" dirty="0"/>
+          </a:p>
+        </p:txBody>
+      </p:sp>
       <p:pic>
         <p:nvPicPr>
-          <p:cNvPr id="7" name="Image 1" descr="/home/user/dillon-os/02_FullTimeJob/AlignHCM/win-stories/world-central-kitchen/assets/align_logo.png">    </p:cNvPr>
+          <p:cNvPr id="9" name="Image 1" descr="/home/user/dillon-os/02_FullTimeJob/AlignHCM/win-stories/world-central-kitchen/assets/align_logo.png">    </p:cNvPr>
           <p:cNvPicPr>
             <a:picLocks noChangeAspect="1"/>
           </p:cNvPicPr>
@@ -1025,7 +1086,7 @@
         </p:blipFill>
         <p:spPr>
           <a:xfrm>
-            <a:off x="9223406" y="704088"/>
+            <a:off x="9223406" y="758952"/>
             <a:ext cx="986784" cy="420624"/>
           </a:xfrm>
           <a:prstGeom prst="rect">
@@ -1035,7 +1096,7 @@
       </p:pic>
       <p:pic>
         <p:nvPicPr>
-          <p:cNvPr id="8" name="Image 2" descr="/home/user/dillon-os/02_FullTimeJob/AlignHCM/win-stories/world-central-kitchen/assets/dayforce_logo.png">    </p:cNvPr>
+          <p:cNvPr id="10" name="Image 2" descr="/home/user/dillon-os/02_FullTimeJob/AlignHCM/win-stories/world-central-kitchen/assets/dayforce_logo.png">    </p:cNvPr>
           <p:cNvPicPr>
             <a:picLocks noChangeAspect="1"/>
           </p:cNvPicPr>
@@ -1049,7 +1110,7 @@
         </p:blipFill>
         <p:spPr>
           <a:xfrm>
-            <a:off x="10502798" y="777274"/>
+            <a:off x="10502798" y="832138"/>
             <a:ext cx="1121969" cy="274253"/>
           </a:xfrm>
           <a:prstGeom prst="rect">
@@ -1057,67 +1118,6 @@
           </a:prstGeom>
         </p:spPr>
       </p:pic>
-      <p:sp>
-        <p:nvSpPr>
-          <p:cNvPr id="9" name="Shape 4"/>
-          <p:cNvSpPr/>
-          <p:nvPr/>
-        </p:nvSpPr>
-        <p:spPr>
-          <a:xfrm>
-            <a:off x="9957743" y="384048"/>
-            <a:ext cx="932688" cy="219456"/>
-          </a:xfrm>
-          <a:prstGeom prst="roundRect">
-            <a:avLst>
-              <a:gd name="adj" fmla="val 20833"/>
-            </a:avLst>
-          </a:prstGeom>
-          <a:solidFill>
-            <a:srgbClr val="E0652F"/>
-          </a:solidFill>
-          <a:ln/>
-        </p:spPr>
-      </p:sp>
-      <p:sp>
-        <p:nvSpPr>
-          <p:cNvPr id="10" name="Text 5"/>
-          <p:cNvSpPr/>
-          <p:nvPr/>
-        </p:nvSpPr>
-        <p:spPr>
-          <a:xfrm>
-            <a:off x="9957743" y="384048"/>
-            <a:ext cx="932688" cy="219456"/>
-          </a:xfrm>
-          <a:prstGeom prst="rect">
-            <a:avLst/>
-          </a:prstGeom>
-          <a:noFill/>
-          <a:ln/>
-        </p:spPr>
-        <p:txBody>
-          <a:bodyPr wrap="square" lIns="0" tIns="0" rIns="0" bIns="0" rtlCol="0" anchor="ctr"/>
-          <a:lstStyle/>
-          <a:p>
-            <a:pPr algn="ctr" indent="0" marL="0">
-              <a:buNone/>
-            </a:pPr>
-            <a:r>
-              <a:rPr lang="en-US" sz="850" b="1" spc="100" kern="0" dirty="0">
-                <a:solidFill>
-                  <a:srgbClr val="FFFFFF"/>
-                </a:solidFill>
-                <a:latin typeface="Calibri" pitchFamily="34" charset="0"/>
-                <a:ea typeface="Calibri" pitchFamily="34" charset="-122"/>
-                <a:cs typeface="Calibri" pitchFamily="34" charset="-120"/>
-              </a:rPr>
-              <a:t>WIN STORY</a:t>
-            </a:r>
-            <a:endParaRPr lang="en-US" sz="850" dirty="0"/>
-          </a:p>
-        </p:txBody>
-      </p:sp>
       <p:sp>
         <p:nvSpPr>
           <p:cNvPr id="11" name="Shape 6"/>

</xml_diff>

<commit_message>
Nudge WIN STORY pill down from the header top edge
Give the top-right WIN STORY pill breathing room below the card's top
edge while keeping clear separation from the vendor logos.

Co-Authored-By: Claude Opus 4.8 <noreply@anthropic.com>
Claude-Session: https://claude.ai/code/session_01VnUaj1D5WX83CgY5qm9dDf
</commit_message>
<xml_diff>
--- a/02_FullTimeJob/AlignHCM/win-stories/world-central-kitchen/WCK_Win_Story.pptx
+++ b/02_FullTimeJob/AlignHCM/win-stories/world-central-kitchen/WCK_Win_Story.pptx
@@ -1017,7 +1017,7 @@
         </p:nvSpPr>
         <p:spPr>
           <a:xfrm>
-            <a:off x="10692079" y="301752"/>
+            <a:off x="10692079" y="402336"/>
             <a:ext cx="932688" cy="219456"/>
           </a:xfrm>
           <a:prstGeom prst="roundRect">
@@ -1039,7 +1039,7 @@
         </p:nvSpPr>
         <p:spPr>
           <a:xfrm>
-            <a:off x="10692079" y="301752"/>
+            <a:off x="10692079" y="402336"/>
             <a:ext cx="932688" cy="219456"/>
           </a:xfrm>
           <a:prstGeom prst="rect">

</xml_diff>